<commit_message>
feat: sync the app with GitHub since the September release candidate
Keep the current store, writing consultation, humanities tools, and partner links on the release branch.

Co-authored-by: Cursor <cursoragent@cursor.com>
</commit_message>
<xml_diff>
--- a/docs/AcadeGate_Pitch_Suppliers_AR.pptx
+++ b/docs/AcadeGate_Pitch_Suppliers_AR.pptx
@@ -3456,7 +3456,7 @@
                 <a:ea typeface="Segoe UI" pitchFamily="34" charset="-122"/>
                 <a:cs typeface="Segoe UI" pitchFamily="34" charset="-120"/>
               </a:rPr>
-              <a:t>AcadeGate · عرض شراكة الموردين · محدّث آب 2026</a:t>
+              <a:t>AcadeGate · عرض شراكة الموردين · محدّث ١٩ سبتمبر ٢٠٢٦</a:t>
             </a:r>
             <a:endParaRPr lang="en-US" sz="1000" dirty="0"/>
           </a:p>
@@ -4716,7 +4716,7 @@
                 <a:ea typeface="Segoe UI" pitchFamily="34" charset="-122"/>
                 <a:cs typeface="Segoe UI" pitchFamily="34" charset="-120"/>
               </a:rPr>
-              <a:t>AcadeGate · عرض شراكة الموردين · محدّث آب 2026</a:t>
+              <a:t>AcadeGate · عرض شراكة الموردين · محدّث ١٩ سبتمبر ٢٠٢٦</a:t>
             </a:r>
             <a:endParaRPr lang="en-US" sz="1000" dirty="0"/>
           </a:p>
@@ -5873,7 +5873,7 @@
                 <a:ea typeface="Segoe UI" pitchFamily="34" charset="-122"/>
                 <a:cs typeface="Segoe UI" pitchFamily="34" charset="-120"/>
               </a:rPr>
-              <a:t>AcadeGate · عرض شراكة الموردين · محدّث آب 2026</a:t>
+              <a:t>AcadeGate · عرض شراكة الموردين · محدّث ١٩ سبتمبر ٢٠٢٦</a:t>
             </a:r>
             <a:endParaRPr lang="en-US" sz="1000" dirty="0"/>
           </a:p>
@@ -6884,7 +6884,7 @@
                 <a:ea typeface="Segoe UI" pitchFamily="34" charset="-122"/>
                 <a:cs typeface="Segoe UI" pitchFamily="34" charset="-120"/>
               </a:rPr>
-              <a:t>AcadeGate · عرض شراكة الموردين · محدّث آب 2026</a:t>
+              <a:t>AcadeGate · عرض شراكة الموردين · محدّث ١٩ سبتمبر ٢٠٢٦</a:t>
             </a:r>
             <a:endParaRPr lang="en-US" sz="1000" dirty="0"/>
           </a:p>
@@ -7856,7 +7856,7 @@
                 <a:ea typeface="Segoe UI" pitchFamily="34" charset="-122"/>
                 <a:cs typeface="Segoe UI" pitchFamily="34" charset="-120"/>
               </a:rPr>
-              <a:t>AcadeGate · عرض شراكة الموردين · محدّث آب 2026</a:t>
+              <a:t>AcadeGate · عرض شراكة الموردين · محدّث ١٩ سبتمبر ٢٠٢٦</a:t>
             </a:r>
             <a:endParaRPr lang="en-US" sz="1000" dirty="0"/>
           </a:p>
@@ -8486,7 +8486,7 @@
                 <a:ea typeface="Segoe UI" pitchFamily="34" charset="-122"/>
                 <a:cs typeface="Segoe UI" pitchFamily="34" charset="-120"/>
               </a:rPr>
-              <a:t>AcadeGate · عرض شراكة الموردين · محدّث آب 2026</a:t>
+              <a:t>AcadeGate · عرض شراكة الموردين · محدّث ١٩ سبتمبر ٢٠٢٦</a:t>
             </a:r>
             <a:endParaRPr lang="en-US" sz="1000" dirty="0"/>
           </a:p>
@@ -10001,7 +10001,7 @@
                 <a:ea typeface="Segoe UI" pitchFamily="34" charset="-122"/>
                 <a:cs typeface="Segoe UI" pitchFamily="34" charset="-120"/>
               </a:rPr>
-              <a:t>AcadeGate · عرض شراكة الموردين · محدّث آب 2026</a:t>
+              <a:t>AcadeGate · عرض شراكة الموردين · محدّث ١٩ سبتمبر ٢٠٢٦</a:t>
             </a:r>
             <a:endParaRPr lang="en-US" sz="1000" dirty="0"/>
           </a:p>
@@ -11512,7 +11512,7 @@
                 <a:ea typeface="Segoe UI" pitchFamily="34" charset="-122"/>
                 <a:cs typeface="Segoe UI" pitchFamily="34" charset="-120"/>
               </a:rPr>
-              <a:t>AcadeGate · عرض شراكة الموردين · محدّث آب 2026</a:t>
+              <a:t>AcadeGate · عرض شراكة الموردين · محدّث ١٩ سبتمبر ٢٠٢٦</a:t>
             </a:r>
             <a:endParaRPr lang="en-US" sz="1000" dirty="0"/>
           </a:p>
@@ -12613,7 +12613,7 @@
                 <a:ea typeface="Segoe UI" pitchFamily="34" charset="-122"/>
                 <a:cs typeface="Segoe UI" pitchFamily="34" charset="-120"/>
               </a:rPr>
-              <a:t>AcadeGate · عرض شراكة الموردين · محدّث آب 2026</a:t>
+              <a:t>AcadeGate · عرض شراكة الموردين · محدّث ١٩ سبتمبر ٢٠٢٦</a:t>
             </a:r>
             <a:endParaRPr lang="en-US" sz="1000" dirty="0"/>
           </a:p>
@@ -13648,7 +13648,7 @@
                 <a:ea typeface="Segoe UI" pitchFamily="34" charset="-122"/>
                 <a:cs typeface="Segoe UI" pitchFamily="34" charset="-120"/>
               </a:rPr>
-              <a:t>AcadeGate · عرض شراكة الموردين · محدّث آب 2026</a:t>
+              <a:t>AcadeGate · عرض شراكة الموردين · محدّث ١٩ سبتمبر ٢٠٢٦</a:t>
             </a:r>
             <a:endParaRPr lang="en-US" sz="1000" dirty="0"/>
           </a:p>
@@ -14865,7 +14865,7 @@
                 <a:ea typeface="Segoe UI" pitchFamily="34" charset="-122"/>
                 <a:cs typeface="Segoe UI" pitchFamily="34" charset="-120"/>
               </a:rPr>
-              <a:t>AcadeGate · عرض شراكة الموردين · محدّث آب 2026</a:t>
+              <a:t>AcadeGate · عرض شراكة الموردين · محدّث ١٩ سبتمبر ٢٠٢٦</a:t>
             </a:r>
             <a:endParaRPr lang="en-US" sz="1000" dirty="0"/>
           </a:p>
@@ -15966,7 +15966,7 @@
                 <a:ea typeface="Segoe UI" pitchFamily="34" charset="-122"/>
                 <a:cs typeface="Segoe UI" pitchFamily="34" charset="-120"/>
               </a:rPr>
-              <a:t>AcadeGate · عرض شراكة الموردين · محدّث آب 2026</a:t>
+              <a:t>AcadeGate · عرض شراكة الموردين · محدّث ١٩ سبتمبر ٢٠٢٦</a:t>
             </a:r>
             <a:endParaRPr lang="en-US" sz="1000" dirty="0"/>
           </a:p>
@@ -17217,7 +17217,7 @@
                 <a:ea typeface="Segoe UI" pitchFamily="34" charset="-122"/>
                 <a:cs typeface="Segoe UI" pitchFamily="34" charset="-120"/>
               </a:rPr>
-              <a:t>AcadeGate · عرض شراكة الموردين · محدّث آب 2026</a:t>
+              <a:t>AcadeGate · عرض شراكة الموردين · محدّث ١٩ سبتمبر ٢٠٢٦</a:t>
             </a:r>
             <a:endParaRPr lang="en-US" sz="1000" dirty="0"/>
           </a:p>
@@ -18752,7 +18752,7 @@
                 <a:ea typeface="Segoe UI" pitchFamily="34" charset="-122"/>
                 <a:cs typeface="Segoe UI" pitchFamily="34" charset="-120"/>
               </a:rPr>
-              <a:t>AcadeGate · عرض شراكة الموردين · محدّث آب 2026</a:t>
+              <a:t>AcadeGate · عرض شراكة الموردين · محدّث ١٩ سبتمبر ٢٠٢٦</a:t>
             </a:r>
             <a:endParaRPr lang="en-US" sz="1000" dirty="0"/>
           </a:p>
@@ -20045,7 +20045,7 @@
                 <a:ea typeface="Segoe UI" pitchFamily="34" charset="-122"/>
                 <a:cs typeface="Segoe UI" pitchFamily="34" charset="-120"/>
               </a:rPr>
-              <a:t>AcadeGate · عرض شراكة الموردين · محدّث آب 2026</a:t>
+              <a:t>AcadeGate · عرض شراكة الموردين · محدّث ١٩ سبتمبر ٢٠٢٦</a:t>
             </a:r>
             <a:endParaRPr lang="en-US" sz="1000" dirty="0"/>
           </a:p>

</xml_diff>